<commit_message>
Student uploads NID, resume and other documents as one PDF
The registration upload was described only as an identity document and
accepted images and Word files. It is now one PDF that holds the
citizenship / NID, the resume and any other certificates, so a company
reviewing an applicant can read the resume it never had before.

- routes/auth.py: only PDF is accepted; clearer message on refusal
- register_student.html: new label and help text explaining the one file
- applicants.html / verifications.html: link renamed to match
- new test TC-27: a non-PDF upload is refused (36 tests, all passing)
- report FR-16, schema table, scope, limitations and future work updated
- figures 4 and 16 and the viva sheet regenerated
- defense deck updated (test count, demo step, limitation, future work)

Co-Authored-By: Claude Opus 5 <noreply@anthropic.com>
Claude-Session: https://claude.ai/code/session_013xPLnyFTSjbxMiATP4c7ND
</commit_message>
<xml_diff>
--- a/docs/Final_Defense_Presentation.pptx
+++ b/docs/Final_Defense_Presentation.pptx
@@ -3627,7 +3627,7 @@
                 <a:ea typeface="Courier New" pitchFamily="34" charset="-122"/>
                 <a:cs typeface="Courier New" pitchFamily="34" charset="-120"/>
               </a:rPr>
-              <a:t>└── tests/            35 tests</a:t>
+              <a:t>└── tests/            36 tests</a:t>
             </a:r>
             <a:endParaRPr lang="en-US" sz="1100" dirty="0"/>
           </a:p>
@@ -5285,7 +5285,7 @@
                 <a:ea typeface="Calibri" pitchFamily="34" charset="-122"/>
                 <a:cs typeface="Calibri" pitchFamily="34" charset="-120"/>
               </a:rPr>
-              <a:t>College is selected and an identity document is uploaded</a:t>
+              <a:t>College is selected and one PDF with NID, resume and documents is uploaded</a:t>
             </a:r>
             <a:endParaRPr lang="en-US" sz="1100" dirty="0"/>
           </a:p>
@@ -7596,7 +7596,7 @@
                 <a:ea typeface="Calibri" pitchFamily="34" charset="-122"/>
                 <a:cs typeface="Calibri" pitchFamily="34" charset="-120"/>
               </a:rPr>
-              <a:t>35 AUTOMATED TESTS, ALL PASSING</a:t>
+              <a:t>36 AUTOMATED TESTS, ALL PASSING</a:t>
             </a:r>
             <a:endParaRPr lang="en-US" sz="1100" dirty="0"/>
           </a:p>
@@ -10135,6 +10135,280 @@
                   </a:tcPr>
                 </a:tc>
               </a:tr>
+              <a:tr h="384048">
+                <a:tc>
+                  <a:txBody>
+                    <a:bodyPr/>
+                    <a:lstStyle/>
+                    <a:p>
+                      <a:pPr indent="0" marL="0">
+                        <a:buNone/>
+                      </a:pPr>
+                      <a:r>
+                        <a:rPr lang="en-US" sz="1100" dirty="0">
+                          <a:solidFill>
+                            <a:srgbClr val="2B3440"/>
+                          </a:solidFill>
+                          <a:latin typeface="Calibri" pitchFamily="34" charset="0"/>
+                          <a:ea typeface="Calibri" pitchFamily="34" charset="-122"/>
+                          <a:cs typeface="Calibri" pitchFamily="34" charset="-120"/>
+                        </a:rPr>
+                        <a:t>Document is not a PDF</a:t>
+                      </a:r>
+                      <a:endParaRPr lang="en-US" sz="1100" dirty="0">
+                        <a:latin typeface="Calibri" charset="0"/>
+                        <a:ea typeface="Calibri" charset="0"/>
+                        <a:cs typeface="Calibri" charset="0"/>
+                      </a:endParaRPr>
+                    </a:p>
+                  </a:txBody>
+                  <a:tcPr marL="91440" marR="91440" marT="45720" marB="45720" anchor="ctr">
+                    <a:lnL w="12700" cap="flat" cmpd="sng" algn="ctr">
+                      <a:solidFill>
+                        <a:srgbClr val="DCE4EF"/>
+                      </a:solidFill>
+                      <a:prstDash val="solid"/>
+                      <a:round/>
+                      <a:headEnd type="none" w="med" len="med"/>
+                      <a:tailEnd type="none" w="med" len="med"/>
+                    </a:lnL>
+                    <a:lnR w="12700" cap="flat" cmpd="sng" algn="ctr">
+                      <a:solidFill>
+                        <a:srgbClr val="DCE4EF"/>
+                      </a:solidFill>
+                      <a:prstDash val="solid"/>
+                      <a:round/>
+                      <a:headEnd type="none" w="med" len="med"/>
+                      <a:tailEnd type="none" w="med" len="med"/>
+                    </a:lnR>
+                    <a:lnT w="12700" cap="flat" cmpd="sng" algn="ctr">
+                      <a:solidFill>
+                        <a:srgbClr val="DCE4EF"/>
+                      </a:solidFill>
+                      <a:prstDash val="solid"/>
+                      <a:round/>
+                      <a:headEnd type="none" w="med" len="med"/>
+                      <a:tailEnd type="none" w="med" len="med"/>
+                    </a:lnT>
+                    <a:lnB w="12700" cap="flat" cmpd="sng" algn="ctr">
+                      <a:solidFill>
+                        <a:srgbClr val="DCE4EF"/>
+                      </a:solidFill>
+                      <a:prstDash val="solid"/>
+                      <a:round/>
+                      <a:headEnd type="none" w="med" len="med"/>
+                      <a:tailEnd type="none" w="med" len="med"/>
+                    </a:lnB>
+                    <a:solidFill>
+                      <a:srgbClr val="FFFFFF"/>
+                    </a:solidFill>
+                  </a:tcPr>
+                </a:tc>
+                <a:tc>
+                  <a:txBody>
+                    <a:bodyPr/>
+                    <a:lstStyle/>
+                    <a:p>
+                      <a:pPr indent="0" marL="0">
+                        <a:buNone/>
+                      </a:pPr>
+                      <a:r>
+                        <a:rPr lang="en-US" sz="1100" dirty="0">
+                          <a:solidFill>
+                            <a:srgbClr val="6B7686"/>
+                          </a:solidFill>
+                          <a:latin typeface="Calibri" pitchFamily="34" charset="0"/>
+                          <a:ea typeface="Calibri" pitchFamily="34" charset="-122"/>
+                          <a:cs typeface="Calibri" pitchFamily="34" charset="-120"/>
+                        </a:rPr>
+                        <a:t>Registration refused, one PDF asked for</a:t>
+                      </a:r>
+                      <a:endParaRPr lang="en-US" sz="1100" dirty="0">
+                        <a:latin typeface="Calibri" charset="0"/>
+                        <a:ea typeface="Calibri" charset="0"/>
+                        <a:cs typeface="Calibri" charset="0"/>
+                      </a:endParaRPr>
+                    </a:p>
+                  </a:txBody>
+                  <a:tcPr marL="91440" marR="91440" marT="45720" marB="45720" anchor="ctr">
+                    <a:lnL w="12700" cap="flat" cmpd="sng" algn="ctr">
+                      <a:solidFill>
+                        <a:srgbClr val="DCE4EF"/>
+                      </a:solidFill>
+                      <a:prstDash val="solid"/>
+                      <a:round/>
+                      <a:headEnd type="none" w="med" len="med"/>
+                      <a:tailEnd type="none" w="med" len="med"/>
+                    </a:lnL>
+                    <a:lnR w="12700" cap="flat" cmpd="sng" algn="ctr">
+                      <a:solidFill>
+                        <a:srgbClr val="DCE4EF"/>
+                      </a:solidFill>
+                      <a:prstDash val="solid"/>
+                      <a:round/>
+                      <a:headEnd type="none" w="med" len="med"/>
+                      <a:tailEnd type="none" w="med" len="med"/>
+                    </a:lnR>
+                    <a:lnT w="12700" cap="flat" cmpd="sng" algn="ctr">
+                      <a:solidFill>
+                        <a:srgbClr val="DCE4EF"/>
+                      </a:solidFill>
+                      <a:prstDash val="solid"/>
+                      <a:round/>
+                      <a:headEnd type="none" w="med" len="med"/>
+                      <a:tailEnd type="none" w="med" len="med"/>
+                    </a:lnT>
+                    <a:lnB w="12700" cap="flat" cmpd="sng" algn="ctr">
+                      <a:solidFill>
+                        <a:srgbClr val="DCE4EF"/>
+                      </a:solidFill>
+                      <a:prstDash val="solid"/>
+                      <a:round/>
+                      <a:headEnd type="none" w="med" len="med"/>
+                      <a:tailEnd type="none" w="med" len="med"/>
+                    </a:lnB>
+                    <a:solidFill>
+                      <a:srgbClr val="FFFFFF"/>
+                    </a:solidFill>
+                  </a:tcPr>
+                </a:tc>
+                <a:tc>
+                  <a:txBody>
+                    <a:bodyPr/>
+                    <a:lstStyle/>
+                    <a:p>
+                      <a:pPr indent="0" marL="0">
+                        <a:buNone/>
+                      </a:pPr>
+                      <a:r>
+                        <a:rPr lang="en-US" sz="1100" dirty="0">
+                          <a:solidFill>
+                            <a:srgbClr val="6B7686"/>
+                          </a:solidFill>
+                          <a:latin typeface="Calibri" pitchFamily="34" charset="0"/>
+                          <a:ea typeface="Calibri" pitchFamily="34" charset="-122"/>
+                          <a:cs typeface="Calibri" pitchFamily="34" charset="-120"/>
+                        </a:rPr>
+                        <a:t>Refused</a:t>
+                      </a:r>
+                      <a:endParaRPr lang="en-US" sz="1100" dirty="0">
+                        <a:latin typeface="Calibri" charset="0"/>
+                        <a:ea typeface="Calibri" charset="0"/>
+                        <a:cs typeface="Calibri" charset="0"/>
+                      </a:endParaRPr>
+                    </a:p>
+                  </a:txBody>
+                  <a:tcPr marL="91440" marR="91440" marT="45720" marB="45720" anchor="ctr">
+                    <a:lnL w="12700" cap="flat" cmpd="sng" algn="ctr">
+                      <a:solidFill>
+                        <a:srgbClr val="DCE4EF"/>
+                      </a:solidFill>
+                      <a:prstDash val="solid"/>
+                      <a:round/>
+                      <a:headEnd type="none" w="med" len="med"/>
+                      <a:tailEnd type="none" w="med" len="med"/>
+                    </a:lnL>
+                    <a:lnR w="12700" cap="flat" cmpd="sng" algn="ctr">
+                      <a:solidFill>
+                        <a:srgbClr val="DCE4EF"/>
+                      </a:solidFill>
+                      <a:prstDash val="solid"/>
+                      <a:round/>
+                      <a:headEnd type="none" w="med" len="med"/>
+                      <a:tailEnd type="none" w="med" len="med"/>
+                    </a:lnR>
+                    <a:lnT w="12700" cap="flat" cmpd="sng" algn="ctr">
+                      <a:solidFill>
+                        <a:srgbClr val="DCE4EF"/>
+                      </a:solidFill>
+                      <a:prstDash val="solid"/>
+                      <a:round/>
+                      <a:headEnd type="none" w="med" len="med"/>
+                      <a:tailEnd type="none" w="med" len="med"/>
+                    </a:lnT>
+                    <a:lnB w="12700" cap="flat" cmpd="sng" algn="ctr">
+                      <a:solidFill>
+                        <a:srgbClr val="DCE4EF"/>
+                      </a:solidFill>
+                      <a:prstDash val="solid"/>
+                      <a:round/>
+                      <a:headEnd type="none" w="med" len="med"/>
+                      <a:tailEnd type="none" w="med" len="med"/>
+                    </a:lnB>
+                    <a:solidFill>
+                      <a:srgbClr val="FFFFFF"/>
+                    </a:solidFill>
+                  </a:tcPr>
+                </a:tc>
+                <a:tc>
+                  <a:txBody>
+                    <a:bodyPr/>
+                    <a:lstStyle/>
+                    <a:p>
+                      <a:pPr algn="ctr" indent="0" marL="0">
+                        <a:buNone/>
+                      </a:pPr>
+                      <a:r>
+                        <a:rPr lang="en-US" sz="1050" b="1" dirty="0">
+                          <a:solidFill>
+                            <a:srgbClr val="1E7A46"/>
+                          </a:solidFill>
+                          <a:latin typeface="Calibri" pitchFamily="34" charset="0"/>
+                          <a:ea typeface="Calibri" pitchFamily="34" charset="-122"/>
+                          <a:cs typeface="Calibri" pitchFamily="34" charset="-120"/>
+                        </a:rPr>
+                        <a:t>PASS</a:t>
+                      </a:r>
+                      <a:endParaRPr lang="en-US" sz="1050" dirty="0">
+                        <a:latin typeface="Calibri" charset="0"/>
+                        <a:ea typeface="Calibri" charset="0"/>
+                        <a:cs typeface="Calibri" charset="0"/>
+                      </a:endParaRPr>
+                    </a:p>
+                  </a:txBody>
+                  <a:tcPr marL="91440" marR="91440" marT="45720" marB="45720" anchor="ctr">
+                    <a:lnL w="12700" cap="flat" cmpd="sng" algn="ctr">
+                      <a:solidFill>
+                        <a:srgbClr val="DCE4EF"/>
+                      </a:solidFill>
+                      <a:prstDash val="solid"/>
+                      <a:round/>
+                      <a:headEnd type="none" w="med" len="med"/>
+                      <a:tailEnd type="none" w="med" len="med"/>
+                    </a:lnL>
+                    <a:lnR w="12700" cap="flat" cmpd="sng" algn="ctr">
+                      <a:solidFill>
+                        <a:srgbClr val="DCE4EF"/>
+                      </a:solidFill>
+                      <a:prstDash val="solid"/>
+                      <a:round/>
+                      <a:headEnd type="none" w="med" len="med"/>
+                      <a:tailEnd type="none" w="med" len="med"/>
+                    </a:lnR>
+                    <a:lnT w="12700" cap="flat" cmpd="sng" algn="ctr">
+                      <a:solidFill>
+                        <a:srgbClr val="DCE4EF"/>
+                      </a:solidFill>
+                      <a:prstDash val="solid"/>
+                      <a:round/>
+                      <a:headEnd type="none" w="med" len="med"/>
+                      <a:tailEnd type="none" w="med" len="med"/>
+                    </a:lnT>
+                    <a:lnB w="12700" cap="flat" cmpd="sng" algn="ctr">
+                      <a:solidFill>
+                        <a:srgbClr val="DCE4EF"/>
+                      </a:solidFill>
+                      <a:prstDash val="solid"/>
+                      <a:round/>
+                      <a:headEnd type="none" w="med" len="med"/>
+                      <a:tailEnd type="none" w="med" len="med"/>
+                    </a:lnB>
+                    <a:solidFill>
+                      <a:srgbClr val="FFFFFF"/>
+                    </a:solidFill>
+                  </a:tcPr>
+                </a:tc>
+              </a:tr>
             </a:tbl>
           </a:graphicData>
         </a:graphic>
@@ -10199,7 +10473,7 @@
                 <a:ea typeface="Cambria" pitchFamily="34" charset="-122"/>
                 <a:cs typeface="Cambria" pitchFamily="34" charset="-120"/>
               </a:rPr>
-              <a:t>35</a:t>
+              <a:t>36</a:t>
             </a:r>
             <a:endParaRPr lang="en-US" sz="5400" dirty="0"/>
           </a:p>
@@ -11164,7 +11438,7 @@
                 <a:ea typeface="Cambria" pitchFamily="34" charset="-122"/>
                 <a:cs typeface="Cambria" pitchFamily="34" charset="-120"/>
               </a:rPr>
-              <a:t>35</a:t>
+              <a:t>36</a:t>
             </a:r>
             <a:endParaRPr lang="en-US" sz="3600" dirty="0"/>
           </a:p>
@@ -13197,7 +13471,7 @@
                 <a:ea typeface="Cambria" pitchFamily="34" charset="-122"/>
                 <a:cs typeface="Cambria" pitchFamily="34" charset="-120"/>
               </a:rPr>
-              <a:t>Limited file handling</a:t>
+              <a:t>One combined file</a:t>
             </a:r>
             <a:endParaRPr lang="en-US" sz="1350" dirty="0"/>
           </a:p>
@@ -13239,7 +13513,7 @@
                 <a:ea typeface="Calibri" pitchFamily="34" charset="-122"/>
                 <a:cs typeface="Calibri" pitchFamily="34" charset="-120"/>
               </a:rPr>
-              <a:t>Only the identity document at registration; no resume upload or log attachments</a:t>
+              <a:t>NID, resume and certificates arrive as a single PDF; the system cannot index them separately</a:t>
             </a:r>
             <a:endParaRPr lang="en-US" sz="1050" dirty="0"/>
           </a:p>
@@ -14550,7 +14824,7 @@
                 <a:ea typeface="Cambria" pitchFamily="34" charset="-122"/>
                 <a:cs typeface="Cambria" pitchFamily="34" charset="-120"/>
               </a:rPr>
-              <a:t>Resume and attachments</a:t>
+              <a:t>Separate document fields</a:t>
             </a:r>
             <a:endParaRPr lang="en-US" sz="1400" dirty="0"/>
           </a:p>
@@ -14592,7 +14866,7 @@
                 <a:ea typeface="Calibri" pitchFamily="34" charset="-122"/>
                 <a:cs typeface="Calibri" pitchFamily="34" charset="-120"/>
               </a:rPr>
-              <a:t>Upload a resume and attach files to weekly logs</a:t>
+              <a:t>A parsed resume field and file attachments on the weekly logs</a:t>
             </a:r>
             <a:endParaRPr lang="en-US" sz="1100" dirty="0"/>
           </a:p>
@@ -22690,7 +22964,7 @@
                 <a:ea typeface="Calibri" pitchFamily="34" charset="-122"/>
                 <a:cs typeface="Calibri" pitchFamily="34" charset="-120"/>
               </a:rPr>
-              <a:t>pytest — 35 tests</a:t>
+              <a:t>pytest — 36 tests</a:t>
             </a:r>
             <a:endParaRPr lang="en-US" sz="1150" dirty="0"/>
           </a:p>

</xml_diff>

<commit_message>
Bring the documents back in line with the ninth table
- Report: nine tables throughout, FR-24 for notifications, TC-22..TC-24
  and the badge-clearing check added, schema Table 4.11 and the
  relationships row restored, the notifications page described in the
  interface section, and the annex figures renumbered around the new
  screenshot. 118 A4 pages.
- Diagrams: ER, DFD level 1, use case and the architecture diagram
  regenerated with notifications.
- Deck: table and test counts, the Notifications feature card, and the
  demo script wording.
- Viva sheet: quick-facts card, ER answer, a new question on how a user
  finds out something happened, and the honest-limitations list back to
  "email and SMS not implemented".
- README: nine tables and the notifications feature.

33 tests pass.

Co-Authored-By: Claude Opus 5 <noreply@anthropic.com>
Claude-Session: https://claude.ai/code/session_013xPLnyFTSjbxMiATP4c7ND
</commit_message>
<xml_diff>
--- a/docs/Final_Defense_Presentation.pptx
+++ b/docs/Final_Defense_Presentation.pptx
@@ -2193,7 +2193,7 @@
           <a:p>
             <a:r>
               <a:rPr lang="en-US" dirty="0"/>
-              <a:t>If asked to name the tables: roles, users, students, companies, supervisors, internships, applications, progress_logs.</a:t>
+              <a:t>If asked to name the tables: roles, users, students, companies, supervisors, internships, applications, progress_logs, notifications.</a:t>
             </a:r>
             <a:endParaRPr lang="en-US" dirty="0"/>
           </a:p>
@@ -3587,7 +3587,7 @@
                 <a:ea typeface="Courier New" pitchFamily="34" charset="-122"/>
                 <a:cs typeface="Courier New" pitchFamily="34" charset="-120"/>
               </a:rPr>
-              <a:t>├── templates/        18 HTML pages</a:t>
+              <a:t>├── templates/        19 HTML pages</a:t>
             </a:r>
             <a:endParaRPr lang="en-US" sz="1100" dirty="0"/>
           </a:p>
@@ -3627,7 +3627,7 @@
                 <a:ea typeface="Courier New" pitchFamily="34" charset="-122"/>
                 <a:cs typeface="Courier New" pitchFamily="34" charset="-120"/>
               </a:rPr>
-              <a:t>└── tests/            29 tests</a:t>
+              <a:t>└── tests/            33 tests</a:t>
             </a:r>
             <a:endParaRPr lang="en-US" sz="1100" dirty="0"/>
           </a:p>
@@ -5873,7 +5873,7 @@
                 <a:ea typeface="Calibri" pitchFamily="34" charset="-122"/>
                 <a:cs typeface="Calibri" pitchFamily="34" charset="-120"/>
               </a:rPr>
-              <a:t>The status changes to selected on the student’s page</a:t>
+              <a:t>The student is notified of the decision</a:t>
             </a:r>
             <a:endParaRPr lang="en-US" sz="1100" dirty="0"/>
           </a:p>
@@ -6167,7 +6167,7 @@
                 <a:ea typeface="Calibri" pitchFamily="34" charset="-122"/>
                 <a:cs typeface="Calibri" pitchFamily="34" charset="-120"/>
               </a:rPr>
-              <a:t>Feedback and marks, visible on the student’s log book</a:t>
+              <a:t>Feedback and marks; the student is notified</a:t>
             </a:r>
             <a:endParaRPr lang="en-US" sz="1100" dirty="0"/>
           </a:p>
@@ -7596,7 +7596,7 @@
                 <a:ea typeface="Calibri" pitchFamily="34" charset="-122"/>
                 <a:cs typeface="Calibri" pitchFamily="34" charset="-120"/>
               </a:rPr>
-              <a:t>29 AUTOMATED TESTS, ALL PASSING</a:t>
+              <a:t>33 AUTOMATED TESTS, ALL PASSING</a:t>
             </a:r>
             <a:endParaRPr lang="en-US" sz="1100" dirty="0"/>
           </a:p>
@@ -10473,7 +10473,7 @@
                 <a:ea typeface="Cambria" pitchFamily="34" charset="-122"/>
                 <a:cs typeface="Cambria" pitchFamily="34" charset="-120"/>
               </a:rPr>
-              <a:t>29</a:t>
+              <a:t>33</a:t>
             </a:r>
             <a:endParaRPr lang="en-US" sz="5400" dirty="0"/>
           </a:p>
@@ -11123,7 +11123,7 @@
                 <a:ea typeface="Cambria" pitchFamily="34" charset="-122"/>
                 <a:cs typeface="Cambria" pitchFamily="34" charset="-120"/>
               </a:rPr>
-              <a:t>8</a:t>
+              <a:t>9</a:t>
             </a:r>
             <a:endParaRPr lang="en-US" sz="3600" dirty="0"/>
           </a:p>
@@ -11333,7 +11333,7 @@
                 <a:ea typeface="Cambria" pitchFamily="34" charset="-122"/>
                 <a:cs typeface="Cambria" pitchFamily="34" charset="-120"/>
               </a:rPr>
-              <a:t>29</a:t>
+              <a:t>30</a:t>
             </a:r>
             <a:endParaRPr lang="en-US" sz="3600" dirty="0"/>
           </a:p>
@@ -11438,7 +11438,7 @@
                 <a:ea typeface="Cambria" pitchFamily="34" charset="-122"/>
                 <a:cs typeface="Cambria" pitchFamily="34" charset="-120"/>
               </a:rPr>
-              <a:t>29</a:t>
+              <a:t>33</a:t>
             </a:r>
             <a:endParaRPr lang="en-US" sz="3600" dirty="0"/>
           </a:p>
@@ -14510,7 +14510,7 @@
                 <a:ea typeface="Cambria" pitchFamily="34" charset="-122"/>
                 <a:cs typeface="Cambria" pitchFamily="34" charset="-120"/>
               </a:rPr>
-              <a:t>Notifications by email</a:t>
+              <a:t>Email delivery</a:t>
             </a:r>
             <a:endParaRPr lang="en-US" sz="1400" dirty="0"/>
           </a:p>
@@ -14552,7 +14552,7 @@
                 <a:ea typeface="Calibri" pitchFamily="34" charset="-122"/>
                 <a:cs typeface="Calibri" pitchFamily="34" charset="-120"/>
               </a:rPr>
-              <a:t>Raise a message on each decision and deliver it by email</a:t>
+              <a:t>Send the notifications the system already generates by email</a:t>
             </a:r>
             <a:endParaRPr lang="en-US" sz="1100" dirty="0"/>
           </a:p>
@@ -20123,7 +20123,7 @@
                 <a:ea typeface="Calibri" pitchFamily="34" charset="-122"/>
                 <a:cs typeface="Calibri" pitchFamily="34" charset="-120"/>
               </a:rPr>
-              <a:t>Eight related</a:t>
+              <a:t>Nine related</a:t>
             </a:r>
             <a:endParaRPr lang="en-US" sz="1100" dirty="0"/>
           </a:p>
@@ -21395,7 +21395,7 @@
                 <a:ea typeface="Cambria" pitchFamily="34" charset="-122"/>
                 <a:cs typeface="Cambria" pitchFamily="34" charset="-120"/>
               </a:rPr>
-              <a:t>Exports and management</a:t>
+              <a:t>Notifications</a:t>
             </a:r>
             <a:endParaRPr lang="en-US" sz="1350" dirty="0"/>
           </a:p>
@@ -21437,7 +21437,7 @@
                 <a:ea typeface="Calibri" pitchFamily="34" charset="-122"/>
                 <a:cs typeface="Calibri" pitchFamily="34" charset="-120"/>
               </a:rPr>
-              <a:t>CSV export of applicants and of the searchable user list</a:t>
+              <a:t>Bell with an unread count for applications, decisions, logs and feedback</a:t>
             </a:r>
             <a:endParaRPr lang="en-US" sz="1080" dirty="0"/>
           </a:p>
@@ -21445,30 +21445,148 @@
       </p:sp>
       <p:sp>
         <p:nvSpPr>
-          <p:cNvPr id="34" name="Text 26"/>
-          <p:cNvSpPr/>
-          <p:nvPr/>
-        </p:nvSpPr>
-        <p:spPr>
-          <a:xfrm>
-            <a:off x="548640" y="6355080"/>
-            <a:ext cx="6400800" cy="274320"/>
-          </a:xfrm>
-          <a:prstGeom prst="rect">
-            <a:avLst/>
-          </a:prstGeom>
-          <a:noFill/>
-          <a:ln/>
-        </p:spPr>
-        <p:txBody>
-          <a:bodyPr wrap="square" lIns="0" tIns="0" rIns="0" bIns="0" rtlCol="0" anchor="ctr"/>
-          <a:lstStyle/>
-          <a:p>
-            <a:pPr indent="0" marL="0">
-              <a:buNone/>
-            </a:pPr>
-            <a:r>
-              <a:rPr lang="en-US" sz="900" dirty="0">
+          <p:cNvPr id="34" name="Shape 26"/>
+          <p:cNvSpPr/>
+          <p:nvPr/>
+        </p:nvSpPr>
+        <p:spPr>
+          <a:xfrm>
+            <a:off x="548640" y="5102352"/>
+            <a:ext cx="5486400" cy="1024128"/>
+          </a:xfrm>
+          <a:prstGeom prst="roundRect">
+            <a:avLst>
+              <a:gd name="adj" fmla="val 8036"/>
+            </a:avLst>
+          </a:prstGeom>
+          <a:solidFill>
+            <a:srgbClr val="F4F7FB"/>
+          </a:solidFill>
+          <a:ln w="12700">
+            <a:solidFill>
+              <a:srgbClr val="DCE4EF"/>
+            </a:solidFill>
+            <a:prstDash val="solid"/>
+          </a:ln>
+        </p:spPr>
+      </p:sp>
+      <p:sp>
+        <p:nvSpPr>
+          <p:cNvPr id="35" name="Shape 27"/>
+          <p:cNvSpPr/>
+          <p:nvPr/>
+        </p:nvSpPr>
+        <p:spPr>
+          <a:xfrm>
+            <a:off x="804672" y="5404104"/>
+            <a:ext cx="420624" cy="420624"/>
+          </a:xfrm>
+          <a:prstGeom prst="ellipse">
+            <a:avLst/>
+          </a:prstGeom>
+          <a:solidFill>
+            <a:srgbClr val="12294D"/>
+          </a:solidFill>
+          <a:ln w="12700">
+            <a:solidFill>
+              <a:srgbClr val="12294D"/>
+            </a:solidFill>
+            <a:prstDash val="solid"/>
+          </a:ln>
+        </p:spPr>
+      </p:sp>
+      <p:pic>
+        <p:nvPicPr>
+          <p:cNvPr id="36" name="Image 6" descr="preencoded.png">    </p:cNvPr>
+          <p:cNvPicPr>
+            <a:picLocks noChangeAspect="1"/>
+          </p:cNvPicPr>
+          <p:nvPr/>
+        </p:nvPicPr>
+        <p:blipFill>
+          <a:blip r:embed="rId7"/>
+          <a:stretch>
+            <a:fillRect/>
+          </a:stretch>
+        </p:blipFill>
+        <p:spPr>
+          <a:xfrm>
+            <a:off x="905622" y="5505054"/>
+            <a:ext cx="218724" cy="218724"/>
+          </a:xfrm>
+          <a:prstGeom prst="rect">
+            <a:avLst/>
+          </a:prstGeom>
+        </p:spPr>
+      </p:pic>
+      <p:sp>
+        <p:nvSpPr>
+          <p:cNvPr id="37" name="Text 28"/>
+          <p:cNvSpPr/>
+          <p:nvPr/>
+        </p:nvSpPr>
+        <p:spPr>
+          <a:xfrm>
+            <a:off x="1389888" y="5285232"/>
+            <a:ext cx="4480560" cy="274320"/>
+          </a:xfrm>
+          <a:prstGeom prst="rect">
+            <a:avLst/>
+          </a:prstGeom>
+          <a:noFill/>
+          <a:ln/>
+        </p:spPr>
+        <p:txBody>
+          <a:bodyPr wrap="square" lIns="0" tIns="0" rIns="0" bIns="0" rtlCol="0" anchor="ctr"/>
+          <a:lstStyle/>
+          <a:p>
+            <a:pPr indent="0" marL="0">
+              <a:buNone/>
+            </a:pPr>
+            <a:r>
+              <a:rPr lang="en-US" sz="1350" b="1" dirty="0">
+                <a:solidFill>
+                  <a:srgbClr val="12294D"/>
+                </a:solidFill>
+                <a:latin typeface="Cambria" pitchFamily="34" charset="0"/>
+                <a:ea typeface="Cambria" pitchFamily="34" charset="-122"/>
+                <a:cs typeface="Cambria" pitchFamily="34" charset="-120"/>
+              </a:rPr>
+              <a:t>Exports and management</a:t>
+            </a:r>
+            <a:endParaRPr lang="en-US" sz="1350" dirty="0"/>
+          </a:p>
+        </p:txBody>
+      </p:sp>
+      <p:sp>
+        <p:nvSpPr>
+          <p:cNvPr id="38" name="Text 29"/>
+          <p:cNvSpPr/>
+          <p:nvPr/>
+        </p:nvSpPr>
+        <p:spPr>
+          <a:xfrm>
+            <a:off x="1389888" y="5577840"/>
+            <a:ext cx="4480560" cy="457200"/>
+          </a:xfrm>
+          <a:prstGeom prst="rect">
+            <a:avLst/>
+          </a:prstGeom>
+          <a:noFill/>
+          <a:ln/>
+        </p:spPr>
+        <p:txBody>
+          <a:bodyPr wrap="square" lIns="0" tIns="0" rIns="0" bIns="0" rtlCol="0" anchor="ctr"/>
+          <a:lstStyle/>
+          <a:p>
+            <a:pPr indent="0" marL="0">
+              <a:lnSpc>
+                <a:spcPts val="1400"/>
+              </a:lnSpc>
+              <a:buNone/>
+            </a:pPr>
+            <a:r>
+              <a:rPr lang="en-US" sz="1080" dirty="0">
                 <a:solidFill>
                   <a:srgbClr val="6B7686"/>
                 </a:solidFill>
@@ -21476,6 +21594,45 @@
                 <a:ea typeface="Calibri" pitchFamily="34" charset="-122"/>
                 <a:cs typeface="Calibri" pitchFamily="34" charset="-120"/>
               </a:rPr>
+              <a:t>CSV export of applicants and of the searchable user list</a:t>
+            </a:r>
+            <a:endParaRPr lang="en-US" sz="1080" dirty="0"/>
+          </a:p>
+        </p:txBody>
+      </p:sp>
+      <p:sp>
+        <p:nvSpPr>
+          <p:cNvPr id="39" name="Text 30"/>
+          <p:cNvSpPr/>
+          <p:nvPr/>
+        </p:nvSpPr>
+        <p:spPr>
+          <a:xfrm>
+            <a:off x="548640" y="6355080"/>
+            <a:ext cx="6400800" cy="274320"/>
+          </a:xfrm>
+          <a:prstGeom prst="rect">
+            <a:avLst/>
+          </a:prstGeom>
+          <a:noFill/>
+          <a:ln/>
+        </p:spPr>
+        <p:txBody>
+          <a:bodyPr wrap="square" lIns="0" tIns="0" rIns="0" bIns="0" rtlCol="0" anchor="ctr"/>
+          <a:lstStyle/>
+          <a:p>
+            <a:pPr indent="0" marL="0">
+              <a:buNone/>
+            </a:pPr>
+            <a:r>
+              <a:rPr lang="en-US" sz="900" dirty="0">
+                <a:solidFill>
+                  <a:srgbClr val="6B7686"/>
+                </a:solidFill>
+                <a:latin typeface="Calibri" pitchFamily="34" charset="0"/>
+                <a:ea typeface="Calibri" pitchFamily="34" charset="-122"/>
+                <a:cs typeface="Calibri" pitchFamily="34" charset="-120"/>
+              </a:rPr>
               <a:t>Internship Portal  ·  Final Project Defense</a:t>
             </a:r>
             <a:endParaRPr lang="en-US" sz="900" dirty="0"/>
@@ -21484,7 +21641,7 @@
       </p:sp>
       <p:sp>
         <p:nvSpPr>
-          <p:cNvPr id="35" name="Text 27"/>
+          <p:cNvPr id="40" name="Text 31"/>
           <p:cNvSpPr/>
           <p:nvPr/>
         </p:nvSpPr>
@@ -22395,7 +22552,7 @@
                 <a:ea typeface="Calibri" pitchFamily="34" charset="-122"/>
                 <a:cs typeface="Calibri" pitchFamily="34" charset="-120"/>
               </a:rPr>
-              <a:t>MySQL — eight related tables</a:t>
+              <a:t>MySQL — nine related tables</a:t>
             </a:r>
             <a:endParaRPr lang="en-US" sz="1150" dirty="0"/>
           </a:p>
@@ -22650,7 +22807,7 @@
                 <a:ea typeface="Calibri" pitchFamily="34" charset="-122"/>
                 <a:cs typeface="Calibri" pitchFamily="34" charset="-120"/>
               </a:rPr>
-              <a:t>pytest — 29 tests</a:t>
+              <a:t>pytest — 33 tests</a:t>
             </a:r>
             <a:endParaRPr lang="en-US" sz="1150" dirty="0"/>
           </a:p>
@@ -23736,7 +23893,7 @@
                 <a:ea typeface="Calibri" pitchFamily="34" charset="-122"/>
                 <a:cs typeface="Calibri" pitchFamily="34" charset="-120"/>
               </a:rPr>
-              <a:t>EIGHT RELATED TABLES</a:t>
+              <a:t>NINE RELATED TABLES</a:t>
             </a:r>
             <a:endParaRPr lang="en-US" sz="1100" dirty="0"/>
           </a:p>

</xml_diff>